<commit_message>
docs(talk-06): plainer wording — drop 'fortnight' for 'about two weeks'
Affects the ownership slide's closing line, the closing line of the
talk, and the matching speaker notes.

Co-Authored-By: Claude Opus 5 <noreply@anthropic.com>
Claude-Session: https://claude.ai/code/session_01SRYxpKayctQCzwbEeQjjDV
</commit_message>
<xml_diff>
--- a/docs/talks/decks/06-rust-for-js-devs.pptx
+++ b/docs/talks/decks/06-rust-for-js-devs.pptx
@@ -688,7 +688,7 @@
           <a:p>
             <a:r>
               <a:rPr lang="en-US" dirty="0"/>
-              <a:t>The on-ramp, three lines. Install rustup — one installer, and it manages versions the way nvm does. cargo new something small. And read the Book, which is free and genuinely good. The recommendation that matters: make your first project a port of a small utility you already wrote in JavaScript. You will be learning one thing, the language, instead of two — the language and the problem. And if you want to read a real one, this project is public: a horror RPG engine whose Rust core runs in the browser, on a server, and on a physical board; the architecture talks are in the same folder as this one. Close on the line: you already know half of it, and the other half is three ideas and a fortnight. Thank you.</a:t>
+              <a:t>The on-ramp, three lines. Install rustup — one installer, and it manages versions the way nvm does. cargo new something small. And read the Book, which is free and genuinely good. The recommendation that matters: make your first project a port of a small utility you already wrote in JavaScript. You will be learning one thing, the language, instead of two — the language and the problem. And if you want to read a real one, this project is public: a horror RPG engine whose Rust core runs in the browser, on a server, and on a physical board; the architecture talks are in the same folder as this one. Close on the line: you already know half of it, and the other half is three ideas and about two weeks. Thank you.</a:t>
             </a:r>
             <a:endParaRPr lang="en-US" dirty="0"/>
           </a:p>
@@ -952,7 +952,7 @@
           <a:p>
             <a:r>
               <a:rPr lang="en-US" dirty="0"/>
-              <a:t>New idea number one, and the only genuinely alien one. On the left, JavaScript you have written: you pass an array to a function, and the call site tells you nothing about whether it mutates — you read the source, or you find out. On the right, the same job in Rust: the ampersand-mut is right there at the call site, so mutation is visible where it happens. Two rules do all the work. First, every value has exactly one owner, and when the owner goes out of scope the value is freed — that is the entire garbage collector, decided at compile time instead of at runtime. Second, everyone else borrows: either a shared read-only reference, or exactly one exclusive mutable one, and the compiler checks every borrow. Then the bottom of the Rust panel, which trips up every newcomer once and never again: assign a vector to a new name and it MOVES — the old name no longer owns it and using it is a compile error. In JavaScript both names would point at the same array and you would go hunting aliasing bugs at runtime; Rust makes you say which one owns it. That is the borrow checker. It is the hard part, it is roughly a fortnight, and then it stops. Delivery: 2 minutes, the biggest single spend in the talk. Do not rush the move example.</a:t>
+              <a:t>New idea number one, and the only genuinely alien one. On the left, JavaScript you have written: you pass an array to a function, and the call site tells you nothing about whether it mutates — you read the source, or you find out. On the right, the same job in Rust: the ampersand-mut is right there at the call site, so mutation is visible where it happens. Two rules do all the work. First, every value has exactly one owner, and when the owner goes out of scope the value is freed — that is the entire garbage collector, decided at compile time instead of at runtime. Second, everyone else borrows: either a shared read-only reference, or exactly one exclusive mutable one, and the compiler checks every borrow. Then the bottom of the Rust panel, which trips up every newcomer once and never again: assign a vector to a new name and it MOVES — the old name no longer owns it and using it is a compile error. In JavaScript both names would point at the same array and you would go hunting aliasing bugs at runtime; Rust makes you say which one owns it. That is the borrow checker. It is the hard part, it takes about two weeks, and then it stops. Delivery: 2 minutes, the biggest single spend in the talk. Do not rush the move example.</a:t>
             </a:r>
             <a:endParaRPr lang="en-US" dirty="0"/>
           </a:p>
@@ -3498,7 +3498,7 @@
                 <a:ea typeface="Calibri" pitchFamily="34" charset="-122"/>
                 <a:cs typeface="Calibri" pitchFamily="34" charset="-120"/>
               </a:rPr>
-              <a:t>You already know half of it. The other half is three ideas and a fortnight.</a:t>
+              <a:t>You already know half of it. The other half is three ideas and about two weeks.</a:t>
             </a:r>
             <a:endParaRPr lang="en-US" sz="1600" dirty="0"/>
           </a:p>
@@ -6209,7 +6209,7 @@
                 <a:ea typeface="Calibri" pitchFamily="34" charset="-122"/>
                 <a:cs typeface="Calibri" pitchFamily="34" charset="-120"/>
               </a:rPr>
-              <a:t>That is the borrow checker — the whole of the hard part, and it is a fortnight of your life.</a:t>
+              <a:t>That is the borrow checker — the whole of the hard part, and it costs you about two weeks.</a:t>
             </a:r>
             <a:endParaRPr lang="en-US" sz="1400" dirty="0"/>
           </a:p>

</xml_diff>